<commit_message>
docs(report): prepare public release
</commit_message>
<xml_diff>
--- a/technical_report/figures/swebench_evolution.pptx
+++ b/technical_report/figures/swebench_evolution.pptx
@@ -5112,7 +5112,7 @@
                 </a:solidFill>
                 <a:latin typeface="Aptos"/>
               </a:rPr>
-              <a:t>Task-mix shift</a:t>
+              <a:t>Composition shift</a:t>
             </a:r>
           </a:p>
         </p:txBody>
@@ -5484,7 +5484,7 @@
                 </a:solidFill>
                 <a:latin typeface="Aptos"/>
               </a:rPr>
-              <a:t>Hard tail</a:t>
+              <a:t>Late difficult tasks</a:t>
             </a:r>
           </a:p>
         </p:txBody>
@@ -6694,7 +6694,7 @@
                 </a:solidFill>
                 <a:latin typeface="Aptos"/>
               </a:rPr>
-              <a:t>Task-mix shift</a:t>
+              <a:t>Composition shift</a:t>
             </a:r>
           </a:p>
         </p:txBody>
@@ -7066,7 +7066,7 @@
                 </a:solidFill>
                 <a:latin typeface="Aptos"/>
               </a:rPr>
-              <a:t>Hard tail</a:t>
+              <a:t>Late difficult tasks</a:t>
             </a:r>
           </a:p>
         </p:txBody>
@@ -7114,8 +7114,8 @@
         </p:nvSpPr>
         <p:spPr>
           <a:xfrm>
-            <a:off x="6611112" y="4199015"/>
-            <a:ext cx="877824" cy="182880"/>
+            <a:off x="6528816" y="4199015"/>
+            <a:ext cx="1042415" cy="182880"/>
           </a:xfrm>
           <a:prstGeom prst="rect">
             <a:avLst/>
@@ -7130,13 +7130,13 @@
           <a:p>
             <a:pPr algn="ctr"/>
             <a:r>
-              <a:rPr sz="750" b="1">
+              <a:rPr sz="720" b="1">
                 <a:solidFill>
                   <a:srgbClr val="C38A20"/>
                 </a:solidFill>
                 <a:latin typeface="Aptos"/>
               </a:rPr>
-              <a:t>task-mix spike</a:t>
+              <a:t>composition shift</a:t>
             </a:r>
           </a:p>
         </p:txBody>
@@ -7171,7 +7171,7 @@
                 </a:solidFill>
                 <a:latin typeface="Aptos"/>
               </a:rPr>
-              <a:t>Task-weighted window means. W13 and W15 were deferred; W23–24 are retained as hard-tail stress. Queue, workspace/container, verifier, infrastructure-retry, and post-task maintenance time are excluded.</a:t>
+              <a:t>Task-weighted window means. Two incomplete Waves are omitted; W23–24 are shown separately as late difficult-task stress. Active time excludes orchestration wait, environment preparation, external verification, infrastructure recovery, and post-task knowledge maintenance.</a:t>
             </a:r>
           </a:p>
         </p:txBody>

</xml_diff>